<commit_message>
feat: Tích hợp crawler IU cổng trường, tính năng Cải thiện điểm GPA theo kỳ và Cố vấn AI DeepSeek
</commit_message>
<xml_diff>
--- a/tổng kết sprint 2/SLIDE_THUYET_TRINH_SPRINT_2_THO_7_MAU.pptx
+++ b/tổng kết sprint 2/SLIDE_THUYET_TRINH_SPRINT_2_THO_7_MAU.pptx
@@ -5,23 +5,23 @@
     <p:sldMasterId id="2147483648" r:id="rId1"/>
   </p:sldMasterIdLst>
   <p:sldIdLst>
-    <p:sldId id="256" r:id="rId7"/>
-    <p:sldId id="257" r:id="rId8"/>
-    <p:sldId id="258" r:id="rId9"/>
-    <p:sldId id="259" r:id="rId10"/>
-    <p:sldId id="260" r:id="rId11"/>
-    <p:sldId id="261" r:id="rId12"/>
-    <p:sldId id="262" r:id="rId13"/>
-    <p:sldId id="263" r:id="rId14"/>
-    <p:sldId id="264" r:id="rId15"/>
-    <p:sldId id="265" r:id="rId16"/>
-    <p:sldId id="266" r:id="rId17"/>
-    <p:sldId id="267" r:id="rId18"/>
-    <p:sldId id="268" r:id="rId19"/>
-    <p:sldId id="269" r:id="rId20"/>
-    <p:sldId id="270" r:id="rId21"/>
+    <p:sldId id="256" r:id="rId2"/>
+    <p:sldId id="257" r:id="rId3"/>
+    <p:sldId id="258" r:id="rId4"/>
+    <p:sldId id="259" r:id="rId5"/>
+    <p:sldId id="260" r:id="rId6"/>
+    <p:sldId id="261" r:id="rId7"/>
+    <p:sldId id="262" r:id="rId8"/>
+    <p:sldId id="263" r:id="rId9"/>
+    <p:sldId id="264" r:id="rId10"/>
+    <p:sldId id="265" r:id="rId11"/>
+    <p:sldId id="266" r:id="rId12"/>
+    <p:sldId id="267" r:id="rId13"/>
+    <p:sldId id="268" r:id="rId14"/>
+    <p:sldId id="269" r:id="rId15"/>
+    <p:sldId id="270" r:id="rId16"/>
   </p:sldIdLst>
-  <p:sldSz cx="12191695" cy="6858000" type="screen4x3"/>
+  <p:sldSz cx="12192000" cy="6858000"/>
   <p:notesSz cx="6858000" cy="9144000"/>
   <p:defaultTextStyle>
     <a:defPPr>
@@ -118,6 +118,22 @@
       </a:defRPr>
     </a:lvl9pPr>
   </p:defaultTextStyle>
+  <p:extLst>
+    <p:ext uri="{EFAFB233-063F-42B5-8137-9DF3F51BA10A}">
+      <p15:sldGuideLst xmlns:p15="http://schemas.microsoft.com/office/powerpoint/2012/main">
+        <p15:guide id="1" orient="horz" pos="2160">
+          <p15:clr>
+            <a:srgbClr val="A4A3A4"/>
+          </p15:clr>
+        </p15:guide>
+        <p15:guide id="2" pos="2880">
+          <p15:clr>
+            <a:srgbClr val="A4A3A4"/>
+          </p15:clr>
+        </p15:guide>
+      </p15:sldGuideLst>
+    </p:ext>
+  </p:extLst>
 </p:presentation>
 </file>
 
@@ -159,10 +175,9 @@
           <a:lstStyle/>
           <a:p>
             <a:r>
-              <a:rPr lang="en-US" smtClean="0"/>
+              <a:rPr lang="en-US"/>
               <a:t>Click to edit Master title style</a:t>
             </a:r>
-            <a:endParaRPr lang="en-US"/>
           </a:p>
         </p:txBody>
       </p:sp>
@@ -278,10 +293,9 @@
           </a:lstStyle>
           <a:p>
             <a:r>
-              <a:rPr lang="en-US" smtClean="0"/>
+              <a:rPr lang="en-US"/>
               <a:t>Click to edit Master subtitle style</a:t>
             </a:r>
-            <a:endParaRPr lang="en-US"/>
           </a:p>
         </p:txBody>
       </p:sp>
@@ -302,7 +316,7 @@
           <a:p>
             <a:fld id="{5BCAD085-E8A6-8845-BD4E-CB4CCA059FC4}" type="datetimeFigureOut">
               <a:rPr lang="en-US" smtClean="0"/>
-              <a:t>1/27/13</a:t>
+              <a:t>10/24/2026</a:t>
             </a:fld>
             <a:endParaRPr lang="en-US"/>
           </a:p>
@@ -396,10 +410,9 @@
           <a:lstStyle/>
           <a:p>
             <a:r>
-              <a:rPr lang="en-US" smtClean="0"/>
+              <a:rPr lang="en-US"/>
               <a:t>Click to edit Master title style</a:t>
             </a:r>
-            <a:endParaRPr lang="en-US"/>
           </a:p>
         </p:txBody>
       </p:sp>
@@ -420,38 +433,37 @@
           <a:p>
             <a:pPr lvl="0"/>
             <a:r>
-              <a:rPr lang="en-US" smtClean="0"/>
+              <a:rPr lang="en-US"/>
               <a:t>Click to edit Master text styles</a:t>
             </a:r>
           </a:p>
           <a:p>
             <a:pPr lvl="1"/>
             <a:r>
-              <a:rPr lang="en-US" smtClean="0"/>
+              <a:rPr lang="en-US"/>
               <a:t>Second level</a:t>
             </a:r>
           </a:p>
           <a:p>
             <a:pPr lvl="2"/>
             <a:r>
-              <a:rPr lang="en-US" smtClean="0"/>
+              <a:rPr lang="en-US"/>
               <a:t>Third level</a:t>
             </a:r>
           </a:p>
           <a:p>
             <a:pPr lvl="3"/>
             <a:r>
-              <a:rPr lang="en-US" smtClean="0"/>
+              <a:rPr lang="en-US"/>
               <a:t>Fourth level</a:t>
             </a:r>
           </a:p>
           <a:p>
             <a:pPr lvl="4"/>
             <a:r>
-              <a:rPr lang="en-US" smtClean="0"/>
+              <a:rPr lang="en-US"/>
               <a:t>Fifth level</a:t>
             </a:r>
-            <a:endParaRPr lang="en-US"/>
           </a:p>
         </p:txBody>
       </p:sp>
@@ -472,7 +484,7 @@
           <a:p>
             <a:fld id="{5BCAD085-E8A6-8845-BD4E-CB4CCA059FC4}" type="datetimeFigureOut">
               <a:rPr lang="en-US" smtClean="0"/>
-              <a:t>1/27/13</a:t>
+              <a:t>10/24/2026</a:t>
             </a:fld>
             <a:endParaRPr lang="en-US"/>
           </a:p>
@@ -571,10 +583,9 @@
           <a:lstStyle/>
           <a:p>
             <a:r>
-              <a:rPr lang="en-US" smtClean="0"/>
+              <a:rPr lang="en-US"/>
               <a:t>Click to edit Master title style</a:t>
             </a:r>
-            <a:endParaRPr lang="en-US"/>
           </a:p>
         </p:txBody>
       </p:sp>
@@ -600,38 +611,37 @@
           <a:p>
             <a:pPr lvl="0"/>
             <a:r>
-              <a:rPr lang="en-US" smtClean="0"/>
+              <a:rPr lang="en-US"/>
               <a:t>Click to edit Master text styles</a:t>
             </a:r>
           </a:p>
           <a:p>
             <a:pPr lvl="1"/>
             <a:r>
-              <a:rPr lang="en-US" smtClean="0"/>
+              <a:rPr lang="en-US"/>
               <a:t>Second level</a:t>
             </a:r>
           </a:p>
           <a:p>
             <a:pPr lvl="2"/>
             <a:r>
-              <a:rPr lang="en-US" smtClean="0"/>
+              <a:rPr lang="en-US"/>
               <a:t>Third level</a:t>
             </a:r>
           </a:p>
           <a:p>
             <a:pPr lvl="3"/>
             <a:r>
-              <a:rPr lang="en-US" smtClean="0"/>
+              <a:rPr lang="en-US"/>
               <a:t>Fourth level</a:t>
             </a:r>
           </a:p>
           <a:p>
             <a:pPr lvl="4"/>
             <a:r>
-              <a:rPr lang="en-US" smtClean="0"/>
+              <a:rPr lang="en-US"/>
               <a:t>Fifth level</a:t>
             </a:r>
-            <a:endParaRPr lang="en-US"/>
           </a:p>
         </p:txBody>
       </p:sp>
@@ -652,7 +662,7 @@
           <a:p>
             <a:fld id="{5BCAD085-E8A6-8845-BD4E-CB4CCA059FC4}" type="datetimeFigureOut">
               <a:rPr lang="en-US" smtClean="0"/>
-              <a:t>1/27/13</a:t>
+              <a:t>10/24/2026</a:t>
             </a:fld>
             <a:endParaRPr lang="en-US"/>
           </a:p>
@@ -746,10 +756,9 @@
           <a:lstStyle/>
           <a:p>
             <a:r>
-              <a:rPr lang="en-US" smtClean="0"/>
+              <a:rPr lang="en-US"/>
               <a:t>Click to edit Master title style</a:t>
             </a:r>
-            <a:endParaRPr lang="en-US"/>
           </a:p>
         </p:txBody>
       </p:sp>
@@ -770,38 +779,37 @@
           <a:p>
             <a:pPr lvl="0"/>
             <a:r>
-              <a:rPr lang="en-US" smtClean="0"/>
+              <a:rPr lang="en-US"/>
               <a:t>Click to edit Master text styles</a:t>
             </a:r>
           </a:p>
           <a:p>
             <a:pPr lvl="1"/>
             <a:r>
-              <a:rPr lang="en-US" smtClean="0"/>
+              <a:rPr lang="en-US"/>
               <a:t>Second level</a:t>
             </a:r>
           </a:p>
           <a:p>
             <a:pPr lvl="2"/>
             <a:r>
-              <a:rPr lang="en-US" smtClean="0"/>
+              <a:rPr lang="en-US"/>
               <a:t>Third level</a:t>
             </a:r>
           </a:p>
           <a:p>
             <a:pPr lvl="3"/>
             <a:r>
-              <a:rPr lang="en-US" smtClean="0"/>
+              <a:rPr lang="en-US"/>
               <a:t>Fourth level</a:t>
             </a:r>
           </a:p>
           <a:p>
             <a:pPr lvl="4"/>
             <a:r>
-              <a:rPr lang="en-US" smtClean="0"/>
+              <a:rPr lang="en-US"/>
               <a:t>Fifth level</a:t>
             </a:r>
-            <a:endParaRPr lang="en-US"/>
           </a:p>
         </p:txBody>
       </p:sp>
@@ -822,7 +830,7 @@
           <a:p>
             <a:fld id="{5BCAD085-E8A6-8845-BD4E-CB4CCA059FC4}" type="datetimeFigureOut">
               <a:rPr lang="en-US" smtClean="0"/>
-              <a:t>1/27/13</a:t>
+              <a:t>10/24/2026</a:t>
             </a:fld>
             <a:endParaRPr lang="en-US"/>
           </a:p>
@@ -925,10 +933,9 @@
           </a:lstStyle>
           <a:p>
             <a:r>
-              <a:rPr lang="en-US" smtClean="0"/>
+              <a:rPr lang="en-US"/>
               <a:t>Click to edit Master title style</a:t>
             </a:r>
-            <a:endParaRPr lang="en-US"/>
           </a:p>
         </p:txBody>
       </p:sp>
@@ -1045,7 +1052,7 @@
           <a:p>
             <a:pPr lvl="0"/>
             <a:r>
-              <a:rPr lang="en-US" smtClean="0"/>
+              <a:rPr lang="en-US"/>
               <a:t>Click to edit Master text styles</a:t>
             </a:r>
           </a:p>
@@ -1068,7 +1075,7 @@
           <a:p>
             <a:fld id="{5BCAD085-E8A6-8845-BD4E-CB4CCA059FC4}" type="datetimeFigureOut">
               <a:rPr lang="en-US" smtClean="0"/>
-              <a:t>1/27/13</a:t>
+              <a:t>10/24/2026</a:t>
             </a:fld>
             <a:endParaRPr lang="en-US"/>
           </a:p>
@@ -1162,10 +1169,9 @@
           <a:lstStyle/>
           <a:p>
             <a:r>
-              <a:rPr lang="en-US" smtClean="0"/>
+              <a:rPr lang="en-US"/>
               <a:t>Click to edit Master title style</a:t>
             </a:r>
-            <a:endParaRPr lang="en-US"/>
           </a:p>
         </p:txBody>
       </p:sp>
@@ -1219,38 +1225,37 @@
           <a:p>
             <a:pPr lvl="0"/>
             <a:r>
-              <a:rPr lang="en-US" smtClean="0"/>
+              <a:rPr lang="en-US"/>
               <a:t>Click to edit Master text styles</a:t>
             </a:r>
           </a:p>
           <a:p>
             <a:pPr lvl="1"/>
             <a:r>
-              <a:rPr lang="en-US" smtClean="0"/>
+              <a:rPr lang="en-US"/>
               <a:t>Second level</a:t>
             </a:r>
           </a:p>
           <a:p>
             <a:pPr lvl="2"/>
             <a:r>
-              <a:rPr lang="en-US" smtClean="0"/>
+              <a:rPr lang="en-US"/>
               <a:t>Third level</a:t>
             </a:r>
           </a:p>
           <a:p>
             <a:pPr lvl="3"/>
             <a:r>
-              <a:rPr lang="en-US" smtClean="0"/>
+              <a:rPr lang="en-US"/>
               <a:t>Fourth level</a:t>
             </a:r>
           </a:p>
           <a:p>
             <a:pPr lvl="4"/>
             <a:r>
-              <a:rPr lang="en-US" smtClean="0"/>
+              <a:rPr lang="en-US"/>
               <a:t>Fifth level</a:t>
             </a:r>
-            <a:endParaRPr lang="en-US"/>
           </a:p>
         </p:txBody>
       </p:sp>
@@ -1304,38 +1309,37 @@
           <a:p>
             <a:pPr lvl="0"/>
             <a:r>
-              <a:rPr lang="en-US" smtClean="0"/>
+              <a:rPr lang="en-US"/>
               <a:t>Click to edit Master text styles</a:t>
             </a:r>
           </a:p>
           <a:p>
             <a:pPr lvl="1"/>
             <a:r>
-              <a:rPr lang="en-US" smtClean="0"/>
+              <a:rPr lang="en-US"/>
               <a:t>Second level</a:t>
             </a:r>
           </a:p>
           <a:p>
             <a:pPr lvl="2"/>
             <a:r>
-              <a:rPr lang="en-US" smtClean="0"/>
+              <a:rPr lang="en-US"/>
               <a:t>Third level</a:t>
             </a:r>
           </a:p>
           <a:p>
             <a:pPr lvl="3"/>
             <a:r>
-              <a:rPr lang="en-US" smtClean="0"/>
+              <a:rPr lang="en-US"/>
               <a:t>Fourth level</a:t>
             </a:r>
           </a:p>
           <a:p>
             <a:pPr lvl="4"/>
             <a:r>
-              <a:rPr lang="en-US" smtClean="0"/>
+              <a:rPr lang="en-US"/>
               <a:t>Fifth level</a:t>
             </a:r>
-            <a:endParaRPr lang="en-US"/>
           </a:p>
         </p:txBody>
       </p:sp>
@@ -1356,7 +1360,7 @@
           <a:p>
             <a:fld id="{5BCAD085-E8A6-8845-BD4E-CB4CCA059FC4}" type="datetimeFigureOut">
               <a:rPr lang="en-US" smtClean="0"/>
-              <a:t>1/27/13</a:t>
+              <a:t>10/24/2026</a:t>
             </a:fld>
             <a:endParaRPr lang="en-US"/>
           </a:p>
@@ -1454,10 +1458,9 @@
           </a:lstStyle>
           <a:p>
             <a:r>
-              <a:rPr lang="en-US" smtClean="0"/>
+              <a:rPr lang="en-US"/>
               <a:t>Click to edit Master title style</a:t>
             </a:r>
-            <a:endParaRPr lang="en-US"/>
           </a:p>
         </p:txBody>
       </p:sp>
@@ -1520,7 +1523,7 @@
           <a:p>
             <a:pPr lvl="0"/>
             <a:r>
-              <a:rPr lang="en-US" smtClean="0"/>
+              <a:rPr lang="en-US"/>
               <a:t>Click to edit Master text styles</a:t>
             </a:r>
           </a:p>
@@ -1576,38 +1579,37 @@
           <a:p>
             <a:pPr lvl="0"/>
             <a:r>
-              <a:rPr lang="en-US" smtClean="0"/>
+              <a:rPr lang="en-US"/>
               <a:t>Click to edit Master text styles</a:t>
             </a:r>
           </a:p>
           <a:p>
             <a:pPr lvl="1"/>
             <a:r>
-              <a:rPr lang="en-US" smtClean="0"/>
+              <a:rPr lang="en-US"/>
               <a:t>Second level</a:t>
             </a:r>
           </a:p>
           <a:p>
             <a:pPr lvl="2"/>
             <a:r>
-              <a:rPr lang="en-US" smtClean="0"/>
+              <a:rPr lang="en-US"/>
               <a:t>Third level</a:t>
             </a:r>
           </a:p>
           <a:p>
             <a:pPr lvl="3"/>
             <a:r>
-              <a:rPr lang="en-US" smtClean="0"/>
+              <a:rPr lang="en-US"/>
               <a:t>Fourth level</a:t>
             </a:r>
           </a:p>
           <a:p>
             <a:pPr lvl="4"/>
             <a:r>
-              <a:rPr lang="en-US" smtClean="0"/>
+              <a:rPr lang="en-US"/>
               <a:t>Fifth level</a:t>
             </a:r>
-            <a:endParaRPr lang="en-US"/>
           </a:p>
         </p:txBody>
       </p:sp>
@@ -1670,7 +1672,7 @@
           <a:p>
             <a:pPr lvl="0"/>
             <a:r>
-              <a:rPr lang="en-US" smtClean="0"/>
+              <a:rPr lang="en-US"/>
               <a:t>Click to edit Master text styles</a:t>
             </a:r>
           </a:p>
@@ -1726,38 +1728,37 @@
           <a:p>
             <a:pPr lvl="0"/>
             <a:r>
-              <a:rPr lang="en-US" smtClean="0"/>
+              <a:rPr lang="en-US"/>
               <a:t>Click to edit Master text styles</a:t>
             </a:r>
           </a:p>
           <a:p>
             <a:pPr lvl="1"/>
             <a:r>
-              <a:rPr lang="en-US" smtClean="0"/>
+              <a:rPr lang="en-US"/>
               <a:t>Second level</a:t>
             </a:r>
           </a:p>
           <a:p>
             <a:pPr lvl="2"/>
             <a:r>
-              <a:rPr lang="en-US" smtClean="0"/>
+              <a:rPr lang="en-US"/>
               <a:t>Third level</a:t>
             </a:r>
           </a:p>
           <a:p>
             <a:pPr lvl="3"/>
             <a:r>
-              <a:rPr lang="en-US" smtClean="0"/>
+              <a:rPr lang="en-US"/>
               <a:t>Fourth level</a:t>
             </a:r>
           </a:p>
           <a:p>
             <a:pPr lvl="4"/>
             <a:r>
-              <a:rPr lang="en-US" smtClean="0"/>
+              <a:rPr lang="en-US"/>
               <a:t>Fifth level</a:t>
             </a:r>
-            <a:endParaRPr lang="en-US"/>
           </a:p>
         </p:txBody>
       </p:sp>
@@ -1778,7 +1779,7 @@
           <a:p>
             <a:fld id="{5BCAD085-E8A6-8845-BD4E-CB4CCA059FC4}" type="datetimeFigureOut">
               <a:rPr lang="en-US" smtClean="0"/>
-              <a:t>1/27/13</a:t>
+              <a:t>10/24/2026</a:t>
             </a:fld>
             <a:endParaRPr lang="en-US"/>
           </a:p>
@@ -1872,10 +1873,9 @@
           <a:lstStyle/>
           <a:p>
             <a:r>
-              <a:rPr lang="en-US" smtClean="0"/>
+              <a:rPr lang="en-US"/>
               <a:t>Click to edit Master title style</a:t>
             </a:r>
-            <a:endParaRPr lang="en-US"/>
           </a:p>
         </p:txBody>
       </p:sp>
@@ -1896,7 +1896,7 @@
           <a:p>
             <a:fld id="{5BCAD085-E8A6-8845-BD4E-CB4CCA059FC4}" type="datetimeFigureOut">
               <a:rPr lang="en-US" smtClean="0"/>
-              <a:t>1/27/13</a:t>
+              <a:t>10/24/2026</a:t>
             </a:fld>
             <a:endParaRPr lang="en-US"/>
           </a:p>
@@ -1991,7 +1991,7 @@
           <a:p>
             <a:fld id="{5BCAD085-E8A6-8845-BD4E-CB4CCA059FC4}" type="datetimeFigureOut">
               <a:rPr lang="en-US" smtClean="0"/>
-              <a:t>1/27/13</a:t>
+              <a:t>10/24/2026</a:t>
             </a:fld>
             <a:endParaRPr lang="en-US"/>
           </a:p>
@@ -2094,10 +2094,9 @@
           </a:lstStyle>
           <a:p>
             <a:r>
-              <a:rPr lang="en-US" smtClean="0"/>
+              <a:rPr lang="en-US"/>
               <a:t>Click to edit Master title style</a:t>
             </a:r>
-            <a:endParaRPr lang="en-US"/>
           </a:p>
         </p:txBody>
       </p:sp>
@@ -2151,38 +2150,37 @@
           <a:p>
             <a:pPr lvl="0"/>
             <a:r>
-              <a:rPr lang="en-US" smtClean="0"/>
+              <a:rPr lang="en-US"/>
               <a:t>Click to edit Master text styles</a:t>
             </a:r>
           </a:p>
           <a:p>
             <a:pPr lvl="1"/>
             <a:r>
-              <a:rPr lang="en-US" smtClean="0"/>
+              <a:rPr lang="en-US"/>
               <a:t>Second level</a:t>
             </a:r>
           </a:p>
           <a:p>
             <a:pPr lvl="2"/>
             <a:r>
-              <a:rPr lang="en-US" smtClean="0"/>
+              <a:rPr lang="en-US"/>
               <a:t>Third level</a:t>
             </a:r>
           </a:p>
           <a:p>
             <a:pPr lvl="3"/>
             <a:r>
-              <a:rPr lang="en-US" smtClean="0"/>
+              <a:rPr lang="en-US"/>
               <a:t>Fourth level</a:t>
             </a:r>
           </a:p>
           <a:p>
             <a:pPr lvl="4"/>
             <a:r>
-              <a:rPr lang="en-US" smtClean="0"/>
+              <a:rPr lang="en-US"/>
               <a:t>Fifth level</a:t>
             </a:r>
-            <a:endParaRPr lang="en-US"/>
           </a:p>
         </p:txBody>
       </p:sp>
@@ -2245,7 +2243,7 @@
           <a:p>
             <a:pPr lvl="0"/>
             <a:r>
-              <a:rPr lang="en-US" smtClean="0"/>
+              <a:rPr lang="en-US"/>
               <a:t>Click to edit Master text styles</a:t>
             </a:r>
           </a:p>
@@ -2268,7 +2266,7 @@
           <a:p>
             <a:fld id="{5BCAD085-E8A6-8845-BD4E-CB4CCA059FC4}" type="datetimeFigureOut">
               <a:rPr lang="en-US" smtClean="0"/>
-              <a:t>1/27/13</a:t>
+              <a:t>10/24/2026</a:t>
             </a:fld>
             <a:endParaRPr lang="en-US"/>
           </a:p>
@@ -2371,10 +2369,9 @@
           </a:lstStyle>
           <a:p>
             <a:r>
-              <a:rPr lang="en-US" smtClean="0"/>
+              <a:rPr lang="en-US"/>
               <a:t>Click to edit Master title style</a:t>
             </a:r>
-            <a:endParaRPr lang="en-US"/>
           </a:p>
         </p:txBody>
       </p:sp>
@@ -2498,7 +2495,7 @@
           <a:p>
             <a:pPr lvl="0"/>
             <a:r>
-              <a:rPr lang="en-US" smtClean="0"/>
+              <a:rPr lang="en-US"/>
               <a:t>Click to edit Master text styles</a:t>
             </a:r>
           </a:p>
@@ -2521,7 +2518,7 @@
           <a:p>
             <a:fld id="{5BCAD085-E8A6-8845-BD4E-CB4CCA059FC4}" type="datetimeFigureOut">
               <a:rPr lang="en-US" smtClean="0"/>
-              <a:t>1/27/13</a:t>
+              <a:t>10/24/2026</a:t>
             </a:fld>
             <a:endParaRPr lang="en-US"/>
           </a:p>
@@ -2630,10 +2627,9 @@
           <a:lstStyle/>
           <a:p>
             <a:r>
-              <a:rPr lang="en-US" smtClean="0"/>
+              <a:rPr lang="en-US"/>
               <a:t>Click to edit Master title style</a:t>
             </a:r>
-            <a:endParaRPr lang="en-US"/>
           </a:p>
         </p:txBody>
       </p:sp>
@@ -2664,38 +2660,37 @@
           <a:p>
             <a:pPr lvl="0"/>
             <a:r>
-              <a:rPr lang="en-US" smtClean="0"/>
+              <a:rPr lang="en-US"/>
               <a:t>Click to edit Master text styles</a:t>
             </a:r>
           </a:p>
           <a:p>
             <a:pPr lvl="1"/>
             <a:r>
-              <a:rPr lang="en-US" smtClean="0"/>
+              <a:rPr lang="en-US"/>
               <a:t>Second level</a:t>
             </a:r>
           </a:p>
           <a:p>
             <a:pPr lvl="2"/>
             <a:r>
-              <a:rPr lang="en-US" smtClean="0"/>
+              <a:rPr lang="en-US"/>
               <a:t>Third level</a:t>
             </a:r>
           </a:p>
           <a:p>
             <a:pPr lvl="3"/>
             <a:r>
-              <a:rPr lang="en-US" smtClean="0"/>
+              <a:rPr lang="en-US"/>
               <a:t>Fourth level</a:t>
             </a:r>
           </a:p>
           <a:p>
             <a:pPr lvl="4"/>
             <a:r>
-              <a:rPr lang="en-US" smtClean="0"/>
+              <a:rPr lang="en-US"/>
               <a:t>Fifth level</a:t>
             </a:r>
-            <a:endParaRPr lang="en-US"/>
           </a:p>
         </p:txBody>
       </p:sp>
@@ -2734,7 +2729,7 @@
           <a:p>
             <a:fld id="{5BCAD085-E8A6-8845-BD4E-CB4CCA059FC4}" type="datetimeFigureOut">
               <a:rPr lang="en-US" smtClean="0"/>
-              <a:t>1/27/13</a:t>
+              <a:t>10/24/2026</a:t>
             </a:fld>
             <a:endParaRPr lang="en-US"/>
           </a:p>
@@ -3093,7 +3088,7 @@
 </file>
 
 <file path=ppt/slides/slide1.xml><?xml version="1.0" encoding="utf-8"?>
-<p:sld xmlns:a="http://schemas.openxmlformats.org/drawingml/2006/main" xmlns:p="http://schemas.openxmlformats.org/presentationml/2006/main" xmlns:r="http://schemas.openxmlformats.org/officeDocument/2006/relationships">
+<p:sld xmlns:a="http://schemas.openxmlformats.org/drawingml/2006/main" xmlns:r="http://schemas.openxmlformats.org/officeDocument/2006/relationships" xmlns:p="http://schemas.openxmlformats.org/presentationml/2006/main">
   <p:cSld>
     <p:spTree>
       <p:nvGrpSpPr>
@@ -3101,7 +3096,14 @@
         <p:cNvGrpSpPr/>
         <p:nvPr/>
       </p:nvGrpSpPr>
-      <p:grpSpPr/>
+      <p:grpSpPr>
+        <a:xfrm>
+          <a:off x="0" y="0"/>
+          <a:ext cx="0" cy="0"/>
+          <a:chOff x="0" y="0"/>
+          <a:chExt cx="0" cy="0"/>
+        </a:xfrm>
+      </p:grpSpPr>
       <p:sp>
         <p:nvSpPr>
           <p:cNvPr id="2" name="Rectangle 1"/>
@@ -3142,6 +3144,7 @@
           <a:lstStyle/>
           <a:p>
             <a:pPr algn="ctr"/>
+            <a:endParaRPr/>
           </a:p>
         </p:txBody>
       </p:sp>
@@ -3185,6 +3188,7 @@
           <a:lstStyle/>
           <a:p>
             <a:pPr algn="ctr"/>
+            <a:endParaRPr/>
           </a:p>
         </p:txBody>
       </p:sp>
@@ -3228,6 +3232,7 @@
           <a:lstStyle/>
           <a:p>
             <a:pPr algn="ctr"/>
+            <a:endParaRPr/>
           </a:p>
         </p:txBody>
       </p:sp>
@@ -3271,6 +3276,7 @@
           <a:lstStyle/>
           <a:p>
             <a:pPr algn="ctr"/>
+            <a:endParaRPr/>
           </a:p>
         </p:txBody>
       </p:sp>
@@ -3314,6 +3320,7 @@
           <a:lstStyle/>
           <a:p>
             <a:pPr algn="ctr"/>
+            <a:endParaRPr/>
           </a:p>
         </p:txBody>
       </p:sp>
@@ -3357,6 +3364,7 @@
           <a:lstStyle/>
           <a:p>
             <a:pPr algn="ctr"/>
+            <a:endParaRPr/>
           </a:p>
         </p:txBody>
       </p:sp>
@@ -3400,6 +3408,7 @@
           <a:lstStyle/>
           <a:p>
             <a:pPr algn="ctr"/>
+            <a:endParaRPr/>
           </a:p>
         </p:txBody>
       </p:sp>
@@ -3443,6 +3452,7 @@
           <a:lstStyle/>
           <a:p>
             <a:pPr algn="ctr"/>
+            <a:endParaRPr/>
           </a:p>
         </p:txBody>
       </p:sp>
@@ -3488,6 +3498,7 @@
           <a:lstStyle/>
           <a:p>
             <a:pPr algn="ctr"/>
+            <a:endParaRPr/>
           </a:p>
         </p:txBody>
       </p:sp>
@@ -3744,7 +3755,7 @@
           </a:fontRef>
         </p:style>
         <p:txBody>
-          <a:bodyPr rtlCol="0" anchor="ctr" wrap="square"/>
+          <a:bodyPr wrap="square" rtlCol="0" anchor="ctr"/>
           <a:lstStyle/>
           <a:p>
             <a:pPr algn="ctr">
@@ -3818,11 +3829,23 @@
   <p:clrMapOvr>
     <a:masterClrMapping/>
   </p:clrMapOvr>
+  <mc:AlternateContent xmlns:mc="http://schemas.openxmlformats.org/markup-compatibility/2006">
+    <mc:Choice xmlns:p159="http://schemas.microsoft.com/office/powerpoint/2015/09/main" Requires="p159">
+      <p:transition xmlns:p14="http://schemas.microsoft.com/office/powerpoint/2010/main" spd="slow" p14:dur="2000">
+        <p159:morph option="byObject"/>
+      </p:transition>
+    </mc:Choice>
+    <mc:Fallback>
+      <p:transition spd="slow">
+        <p:fade/>
+      </p:transition>
+    </mc:Fallback>
+  </mc:AlternateContent>
 </p:sld>
 </file>
 
 <file path=ppt/slides/slide10.xml><?xml version="1.0" encoding="utf-8"?>
-<p:sld xmlns:a="http://schemas.openxmlformats.org/drawingml/2006/main" xmlns:p="http://schemas.openxmlformats.org/presentationml/2006/main" xmlns:r="http://schemas.openxmlformats.org/officeDocument/2006/relationships">
+<p:sld xmlns:a="http://schemas.openxmlformats.org/drawingml/2006/main" xmlns:r="http://schemas.openxmlformats.org/officeDocument/2006/relationships" xmlns:p="http://schemas.openxmlformats.org/presentationml/2006/main">
   <p:cSld>
     <p:spTree>
       <p:nvGrpSpPr>
@@ -3830,7 +3853,14 @@
         <p:cNvGrpSpPr/>
         <p:nvPr/>
       </p:nvGrpSpPr>
-      <p:grpSpPr/>
+      <p:grpSpPr>
+        <a:xfrm>
+          <a:off x="0" y="0"/>
+          <a:ext cx="0" cy="0"/>
+          <a:chOff x="0" y="0"/>
+          <a:chExt cx="0" cy="0"/>
+        </a:xfrm>
+      </p:grpSpPr>
       <p:sp>
         <p:nvSpPr>
           <p:cNvPr id="2" name="Rectangle 1"/>
@@ -3871,6 +3901,7 @@
           <a:lstStyle/>
           <a:p>
             <a:pPr algn="ctr"/>
+            <a:endParaRPr/>
           </a:p>
         </p:txBody>
       </p:sp>
@@ -3914,6 +3945,7 @@
           <a:lstStyle/>
           <a:p>
             <a:pPr algn="ctr"/>
+            <a:endParaRPr/>
           </a:p>
         </p:txBody>
       </p:sp>
@@ -3957,6 +3989,7 @@
           <a:lstStyle/>
           <a:p>
             <a:pPr algn="ctr"/>
+            <a:endParaRPr/>
           </a:p>
         </p:txBody>
       </p:sp>
@@ -4000,6 +4033,7 @@
           <a:lstStyle/>
           <a:p>
             <a:pPr algn="ctr"/>
+            <a:endParaRPr/>
           </a:p>
         </p:txBody>
       </p:sp>
@@ -4043,6 +4077,7 @@
           <a:lstStyle/>
           <a:p>
             <a:pPr algn="ctr"/>
+            <a:endParaRPr/>
           </a:p>
         </p:txBody>
       </p:sp>
@@ -4086,6 +4121,7 @@
           <a:lstStyle/>
           <a:p>
             <a:pPr algn="ctr"/>
+            <a:endParaRPr/>
           </a:p>
         </p:txBody>
       </p:sp>
@@ -4129,6 +4165,7 @@
           <a:lstStyle/>
           <a:p>
             <a:pPr algn="ctr"/>
+            <a:endParaRPr/>
           </a:p>
         </p:txBody>
       </p:sp>
@@ -4172,6 +4209,7 @@
           <a:lstStyle/>
           <a:p>
             <a:pPr algn="ctr"/>
+            <a:endParaRPr/>
           </a:p>
         </p:txBody>
       </p:sp>
@@ -4213,7 +4251,7 @@
           </a:fontRef>
         </p:style>
         <p:txBody>
-          <a:bodyPr rtlCol="0" anchor="ctr" wrap="none"/>
+          <a:bodyPr wrap="none" rtlCol="0" anchor="ctr"/>
           <a:lstStyle/>
           <a:p>
             <a:pPr algn="ctr">
@@ -4363,6 +4401,7 @@
           <a:lstStyle/>
           <a:p>
             <a:pPr algn="ctr"/>
+            <a:endParaRPr/>
           </a:p>
         </p:txBody>
       </p:sp>
@@ -4505,6 +4544,7 @@
           <a:lstStyle/>
           <a:p>
             <a:pPr algn="ctr"/>
+            <a:endParaRPr/>
           </a:p>
         </p:txBody>
       </p:sp>
@@ -4611,11 +4651,23 @@
   <p:clrMapOvr>
     <a:masterClrMapping/>
   </p:clrMapOvr>
+  <mc:AlternateContent xmlns:mc="http://schemas.openxmlformats.org/markup-compatibility/2006">
+    <mc:Choice xmlns:p159="http://schemas.microsoft.com/office/powerpoint/2015/09/main" Requires="p159">
+      <p:transition xmlns:p14="http://schemas.microsoft.com/office/powerpoint/2010/main" spd="slow" p14:dur="2000">
+        <p159:morph option="byObject"/>
+      </p:transition>
+    </mc:Choice>
+    <mc:Fallback>
+      <p:transition spd="slow">
+        <p:fade/>
+      </p:transition>
+    </mc:Fallback>
+  </mc:AlternateContent>
 </p:sld>
 </file>
 
 <file path=ppt/slides/slide11.xml><?xml version="1.0" encoding="utf-8"?>
-<p:sld xmlns:a="http://schemas.openxmlformats.org/drawingml/2006/main" xmlns:p="http://schemas.openxmlformats.org/presentationml/2006/main" xmlns:r="http://schemas.openxmlformats.org/officeDocument/2006/relationships">
+<p:sld xmlns:a="http://schemas.openxmlformats.org/drawingml/2006/main" xmlns:r="http://schemas.openxmlformats.org/officeDocument/2006/relationships" xmlns:p="http://schemas.openxmlformats.org/presentationml/2006/main">
   <p:cSld>
     <p:spTree>
       <p:nvGrpSpPr>
@@ -4623,7 +4675,14 @@
         <p:cNvGrpSpPr/>
         <p:nvPr/>
       </p:nvGrpSpPr>
-      <p:grpSpPr/>
+      <p:grpSpPr>
+        <a:xfrm>
+          <a:off x="0" y="0"/>
+          <a:ext cx="0" cy="0"/>
+          <a:chOff x="0" y="0"/>
+          <a:chExt cx="0" cy="0"/>
+        </a:xfrm>
+      </p:grpSpPr>
       <p:sp>
         <p:nvSpPr>
           <p:cNvPr id="2" name="Rectangle 1"/>
@@ -4664,6 +4723,7 @@
           <a:lstStyle/>
           <a:p>
             <a:pPr algn="ctr"/>
+            <a:endParaRPr/>
           </a:p>
         </p:txBody>
       </p:sp>
@@ -4707,6 +4767,7 @@
           <a:lstStyle/>
           <a:p>
             <a:pPr algn="ctr"/>
+            <a:endParaRPr/>
           </a:p>
         </p:txBody>
       </p:sp>
@@ -4750,6 +4811,7 @@
           <a:lstStyle/>
           <a:p>
             <a:pPr algn="ctr"/>
+            <a:endParaRPr/>
           </a:p>
         </p:txBody>
       </p:sp>
@@ -4793,6 +4855,7 @@
           <a:lstStyle/>
           <a:p>
             <a:pPr algn="ctr"/>
+            <a:endParaRPr/>
           </a:p>
         </p:txBody>
       </p:sp>
@@ -4836,6 +4899,7 @@
           <a:lstStyle/>
           <a:p>
             <a:pPr algn="ctr"/>
+            <a:endParaRPr/>
           </a:p>
         </p:txBody>
       </p:sp>
@@ -4879,6 +4943,7 @@
           <a:lstStyle/>
           <a:p>
             <a:pPr algn="ctr"/>
+            <a:endParaRPr/>
           </a:p>
         </p:txBody>
       </p:sp>
@@ -4922,6 +4987,7 @@
           <a:lstStyle/>
           <a:p>
             <a:pPr algn="ctr"/>
+            <a:endParaRPr/>
           </a:p>
         </p:txBody>
       </p:sp>
@@ -4965,6 +5031,7 @@
           <a:lstStyle/>
           <a:p>
             <a:pPr algn="ctr"/>
+            <a:endParaRPr/>
           </a:p>
         </p:txBody>
       </p:sp>
@@ -5006,7 +5073,7 @@
           </a:fontRef>
         </p:style>
         <p:txBody>
-          <a:bodyPr rtlCol="0" anchor="ctr" wrap="none"/>
+          <a:bodyPr wrap="none" rtlCol="0" anchor="ctr"/>
           <a:lstStyle/>
           <a:p>
             <a:pPr algn="ctr">
@@ -5156,6 +5223,7 @@
           <a:lstStyle/>
           <a:p>
             <a:pPr algn="ctr"/>
+            <a:endParaRPr/>
           </a:p>
         </p:txBody>
       </p:sp>
@@ -5298,6 +5366,7 @@
           <a:lstStyle/>
           <a:p>
             <a:pPr algn="ctr"/>
+            <a:endParaRPr/>
           </a:p>
         </p:txBody>
       </p:sp>
@@ -5400,11 +5469,23 @@
   <p:clrMapOvr>
     <a:masterClrMapping/>
   </p:clrMapOvr>
+  <mc:AlternateContent xmlns:mc="http://schemas.openxmlformats.org/markup-compatibility/2006">
+    <mc:Choice xmlns:p159="http://schemas.microsoft.com/office/powerpoint/2015/09/main" Requires="p159">
+      <p:transition xmlns:p14="http://schemas.microsoft.com/office/powerpoint/2010/main" spd="slow" p14:dur="2000">
+        <p159:morph option="byObject"/>
+      </p:transition>
+    </mc:Choice>
+    <mc:Fallback>
+      <p:transition spd="slow">
+        <p:fade/>
+      </p:transition>
+    </mc:Fallback>
+  </mc:AlternateContent>
 </p:sld>
 </file>
 
 <file path=ppt/slides/slide12.xml><?xml version="1.0" encoding="utf-8"?>
-<p:sld xmlns:a="http://schemas.openxmlformats.org/drawingml/2006/main" xmlns:p="http://schemas.openxmlformats.org/presentationml/2006/main" xmlns:r="http://schemas.openxmlformats.org/officeDocument/2006/relationships">
+<p:sld xmlns:a="http://schemas.openxmlformats.org/drawingml/2006/main" xmlns:r="http://schemas.openxmlformats.org/officeDocument/2006/relationships" xmlns:p="http://schemas.openxmlformats.org/presentationml/2006/main">
   <p:cSld>
     <p:spTree>
       <p:nvGrpSpPr>
@@ -5412,7 +5493,14 @@
         <p:cNvGrpSpPr/>
         <p:nvPr/>
       </p:nvGrpSpPr>
-      <p:grpSpPr/>
+      <p:grpSpPr>
+        <a:xfrm>
+          <a:off x="0" y="0"/>
+          <a:ext cx="0" cy="0"/>
+          <a:chOff x="0" y="0"/>
+          <a:chExt cx="0" cy="0"/>
+        </a:xfrm>
+      </p:grpSpPr>
       <p:sp>
         <p:nvSpPr>
           <p:cNvPr id="2" name="Rectangle 1"/>
@@ -5453,6 +5541,7 @@
           <a:lstStyle/>
           <a:p>
             <a:pPr algn="ctr"/>
+            <a:endParaRPr/>
           </a:p>
         </p:txBody>
       </p:sp>
@@ -5496,6 +5585,7 @@
           <a:lstStyle/>
           <a:p>
             <a:pPr algn="ctr"/>
+            <a:endParaRPr/>
           </a:p>
         </p:txBody>
       </p:sp>
@@ -5539,6 +5629,7 @@
           <a:lstStyle/>
           <a:p>
             <a:pPr algn="ctr"/>
+            <a:endParaRPr/>
           </a:p>
         </p:txBody>
       </p:sp>
@@ -5582,6 +5673,7 @@
           <a:lstStyle/>
           <a:p>
             <a:pPr algn="ctr"/>
+            <a:endParaRPr/>
           </a:p>
         </p:txBody>
       </p:sp>
@@ -5625,6 +5717,7 @@
           <a:lstStyle/>
           <a:p>
             <a:pPr algn="ctr"/>
+            <a:endParaRPr/>
           </a:p>
         </p:txBody>
       </p:sp>
@@ -5668,6 +5761,7 @@
           <a:lstStyle/>
           <a:p>
             <a:pPr algn="ctr"/>
+            <a:endParaRPr/>
           </a:p>
         </p:txBody>
       </p:sp>
@@ -5711,6 +5805,7 @@
           <a:lstStyle/>
           <a:p>
             <a:pPr algn="ctr"/>
+            <a:endParaRPr/>
           </a:p>
         </p:txBody>
       </p:sp>
@@ -5754,6 +5849,7 @@
           <a:lstStyle/>
           <a:p>
             <a:pPr algn="ctr"/>
+            <a:endParaRPr/>
           </a:p>
         </p:txBody>
       </p:sp>
@@ -5795,7 +5891,7 @@
           </a:fontRef>
         </p:style>
         <p:txBody>
-          <a:bodyPr rtlCol="0" anchor="ctr" wrap="none"/>
+          <a:bodyPr wrap="none" rtlCol="0" anchor="ctr"/>
           <a:lstStyle/>
           <a:p>
             <a:pPr algn="ctr">
@@ -5945,6 +6041,7 @@
           <a:lstStyle/>
           <a:p>
             <a:pPr algn="ctr"/>
+            <a:endParaRPr/>
           </a:p>
         </p:txBody>
       </p:sp>
@@ -6088,6 +6185,7 @@
           <a:lstStyle/>
           <a:p>
             <a:pPr algn="ctr"/>
+            <a:endParaRPr/>
           </a:p>
         </p:txBody>
       </p:sp>
@@ -6194,11 +6292,23 @@
   <p:clrMapOvr>
     <a:masterClrMapping/>
   </p:clrMapOvr>
+  <mc:AlternateContent xmlns:mc="http://schemas.openxmlformats.org/markup-compatibility/2006">
+    <mc:Choice xmlns:p159="http://schemas.microsoft.com/office/powerpoint/2015/09/main" Requires="p159">
+      <p:transition xmlns:p14="http://schemas.microsoft.com/office/powerpoint/2010/main" spd="slow" p14:dur="2000">
+        <p159:morph option="byObject"/>
+      </p:transition>
+    </mc:Choice>
+    <mc:Fallback>
+      <p:transition spd="slow">
+        <p:fade/>
+      </p:transition>
+    </mc:Fallback>
+  </mc:AlternateContent>
 </p:sld>
 </file>
 
 <file path=ppt/slides/slide13.xml><?xml version="1.0" encoding="utf-8"?>
-<p:sld xmlns:a="http://schemas.openxmlformats.org/drawingml/2006/main" xmlns:p="http://schemas.openxmlformats.org/presentationml/2006/main" xmlns:r="http://schemas.openxmlformats.org/officeDocument/2006/relationships">
+<p:sld xmlns:a="http://schemas.openxmlformats.org/drawingml/2006/main" xmlns:r="http://schemas.openxmlformats.org/officeDocument/2006/relationships" xmlns:p="http://schemas.openxmlformats.org/presentationml/2006/main">
   <p:cSld>
     <p:spTree>
       <p:nvGrpSpPr>
@@ -6206,7 +6316,14 @@
         <p:cNvGrpSpPr/>
         <p:nvPr/>
       </p:nvGrpSpPr>
-      <p:grpSpPr/>
+      <p:grpSpPr>
+        <a:xfrm>
+          <a:off x="0" y="0"/>
+          <a:ext cx="0" cy="0"/>
+          <a:chOff x="0" y="0"/>
+          <a:chExt cx="0" cy="0"/>
+        </a:xfrm>
+      </p:grpSpPr>
       <p:sp>
         <p:nvSpPr>
           <p:cNvPr id="2" name="Rectangle 1"/>
@@ -6247,6 +6364,7 @@
           <a:lstStyle/>
           <a:p>
             <a:pPr algn="ctr"/>
+            <a:endParaRPr/>
           </a:p>
         </p:txBody>
       </p:sp>
@@ -6290,6 +6408,7 @@
           <a:lstStyle/>
           <a:p>
             <a:pPr algn="ctr"/>
+            <a:endParaRPr/>
           </a:p>
         </p:txBody>
       </p:sp>
@@ -6333,6 +6452,7 @@
           <a:lstStyle/>
           <a:p>
             <a:pPr algn="ctr"/>
+            <a:endParaRPr/>
           </a:p>
         </p:txBody>
       </p:sp>
@@ -6376,6 +6496,7 @@
           <a:lstStyle/>
           <a:p>
             <a:pPr algn="ctr"/>
+            <a:endParaRPr/>
           </a:p>
         </p:txBody>
       </p:sp>
@@ -6419,6 +6540,7 @@
           <a:lstStyle/>
           <a:p>
             <a:pPr algn="ctr"/>
+            <a:endParaRPr/>
           </a:p>
         </p:txBody>
       </p:sp>
@@ -6462,6 +6584,7 @@
           <a:lstStyle/>
           <a:p>
             <a:pPr algn="ctr"/>
+            <a:endParaRPr/>
           </a:p>
         </p:txBody>
       </p:sp>
@@ -6505,6 +6628,7 @@
           <a:lstStyle/>
           <a:p>
             <a:pPr algn="ctr"/>
+            <a:endParaRPr/>
           </a:p>
         </p:txBody>
       </p:sp>
@@ -6548,6 +6672,7 @@
           <a:lstStyle/>
           <a:p>
             <a:pPr algn="ctr"/>
+            <a:endParaRPr/>
           </a:p>
         </p:txBody>
       </p:sp>
@@ -6589,7 +6714,7 @@
           </a:fontRef>
         </p:style>
         <p:txBody>
-          <a:bodyPr rtlCol="0" anchor="ctr" wrap="none"/>
+          <a:bodyPr wrap="none" rtlCol="0" anchor="ctr"/>
           <a:lstStyle/>
           <a:p>
             <a:pPr algn="ctr">
@@ -6739,6 +6864,7 @@
           <a:lstStyle/>
           <a:p>
             <a:pPr algn="ctr"/>
+            <a:endParaRPr/>
           </a:p>
         </p:txBody>
       </p:sp>
@@ -6890,6 +7016,7 @@
           <a:lstStyle/>
           <a:p>
             <a:pPr algn="ctr"/>
+            <a:endParaRPr/>
           </a:p>
         </p:txBody>
       </p:sp>
@@ -6983,11 +7110,23 @@
   <p:clrMapOvr>
     <a:masterClrMapping/>
   </p:clrMapOvr>
+  <mc:AlternateContent xmlns:mc="http://schemas.openxmlformats.org/markup-compatibility/2006">
+    <mc:Choice xmlns:p159="http://schemas.microsoft.com/office/powerpoint/2015/09/main" Requires="p159">
+      <p:transition xmlns:p14="http://schemas.microsoft.com/office/powerpoint/2010/main" spd="slow" p14:dur="2000">
+        <p159:morph option="byObject"/>
+      </p:transition>
+    </mc:Choice>
+    <mc:Fallback>
+      <p:transition spd="slow">
+        <p:fade/>
+      </p:transition>
+    </mc:Fallback>
+  </mc:AlternateContent>
 </p:sld>
 </file>
 
 <file path=ppt/slides/slide14.xml><?xml version="1.0" encoding="utf-8"?>
-<p:sld xmlns:a="http://schemas.openxmlformats.org/drawingml/2006/main" xmlns:p="http://schemas.openxmlformats.org/presentationml/2006/main" xmlns:r="http://schemas.openxmlformats.org/officeDocument/2006/relationships">
+<p:sld xmlns:a="http://schemas.openxmlformats.org/drawingml/2006/main" xmlns:r="http://schemas.openxmlformats.org/officeDocument/2006/relationships" xmlns:p="http://schemas.openxmlformats.org/presentationml/2006/main">
   <p:cSld>
     <p:spTree>
       <p:nvGrpSpPr>
@@ -6995,7 +7134,14 @@
         <p:cNvGrpSpPr/>
         <p:nvPr/>
       </p:nvGrpSpPr>
-      <p:grpSpPr/>
+      <p:grpSpPr>
+        <a:xfrm>
+          <a:off x="0" y="0"/>
+          <a:ext cx="0" cy="0"/>
+          <a:chOff x="0" y="0"/>
+          <a:chExt cx="0" cy="0"/>
+        </a:xfrm>
+      </p:grpSpPr>
       <p:sp>
         <p:nvSpPr>
           <p:cNvPr id="2" name="Rectangle 1"/>
@@ -7036,6 +7182,7 @@
           <a:lstStyle/>
           <a:p>
             <a:pPr algn="ctr"/>
+            <a:endParaRPr/>
           </a:p>
         </p:txBody>
       </p:sp>
@@ -7079,6 +7226,7 @@
           <a:lstStyle/>
           <a:p>
             <a:pPr algn="ctr"/>
+            <a:endParaRPr/>
           </a:p>
         </p:txBody>
       </p:sp>
@@ -7122,6 +7270,7 @@
           <a:lstStyle/>
           <a:p>
             <a:pPr algn="ctr"/>
+            <a:endParaRPr/>
           </a:p>
         </p:txBody>
       </p:sp>
@@ -7165,6 +7314,7 @@
           <a:lstStyle/>
           <a:p>
             <a:pPr algn="ctr"/>
+            <a:endParaRPr/>
           </a:p>
         </p:txBody>
       </p:sp>
@@ -7208,6 +7358,7 @@
           <a:lstStyle/>
           <a:p>
             <a:pPr algn="ctr"/>
+            <a:endParaRPr/>
           </a:p>
         </p:txBody>
       </p:sp>
@@ -7251,6 +7402,7 @@
           <a:lstStyle/>
           <a:p>
             <a:pPr algn="ctr"/>
+            <a:endParaRPr/>
           </a:p>
         </p:txBody>
       </p:sp>
@@ -7294,6 +7446,7 @@
           <a:lstStyle/>
           <a:p>
             <a:pPr algn="ctr"/>
+            <a:endParaRPr/>
           </a:p>
         </p:txBody>
       </p:sp>
@@ -7337,6 +7490,7 @@
           <a:lstStyle/>
           <a:p>
             <a:pPr algn="ctr"/>
+            <a:endParaRPr/>
           </a:p>
         </p:txBody>
       </p:sp>
@@ -7378,7 +7532,7 @@
           </a:fontRef>
         </p:style>
         <p:txBody>
-          <a:bodyPr rtlCol="0" anchor="ctr" wrap="none"/>
+          <a:bodyPr wrap="none" rtlCol="0" anchor="ctr"/>
           <a:lstStyle/>
           <a:p>
             <a:pPr algn="ctr">
@@ -7528,6 +7682,7 @@
           <a:lstStyle/>
           <a:p>
             <a:pPr algn="ctr"/>
+            <a:endParaRPr/>
           </a:p>
         </p:txBody>
       </p:sp>
@@ -7669,6 +7824,7 @@
           <a:lstStyle/>
           <a:p>
             <a:pPr algn="ctr"/>
+            <a:endParaRPr/>
           </a:p>
         </p:txBody>
       </p:sp>
@@ -7783,11 +7939,23 @@
   <p:clrMapOvr>
     <a:masterClrMapping/>
   </p:clrMapOvr>
+  <mc:AlternateContent xmlns:mc="http://schemas.openxmlformats.org/markup-compatibility/2006">
+    <mc:Choice xmlns:p159="http://schemas.microsoft.com/office/powerpoint/2015/09/main" Requires="p159">
+      <p:transition xmlns:p14="http://schemas.microsoft.com/office/powerpoint/2010/main" spd="slow" p14:dur="2000">
+        <p159:morph option="byObject"/>
+      </p:transition>
+    </mc:Choice>
+    <mc:Fallback>
+      <p:transition spd="slow">
+        <p:fade/>
+      </p:transition>
+    </mc:Fallback>
+  </mc:AlternateContent>
 </p:sld>
 </file>
 
 <file path=ppt/slides/slide15.xml><?xml version="1.0" encoding="utf-8"?>
-<p:sld xmlns:a="http://schemas.openxmlformats.org/drawingml/2006/main" xmlns:p="http://schemas.openxmlformats.org/presentationml/2006/main" xmlns:r="http://schemas.openxmlformats.org/officeDocument/2006/relationships">
+<p:sld xmlns:a="http://schemas.openxmlformats.org/drawingml/2006/main" xmlns:r="http://schemas.openxmlformats.org/officeDocument/2006/relationships" xmlns:p="http://schemas.openxmlformats.org/presentationml/2006/main">
   <p:cSld>
     <p:spTree>
       <p:nvGrpSpPr>
@@ -7795,7 +7963,14 @@
         <p:cNvGrpSpPr/>
         <p:nvPr/>
       </p:nvGrpSpPr>
-      <p:grpSpPr/>
+      <p:grpSpPr>
+        <a:xfrm>
+          <a:off x="0" y="0"/>
+          <a:ext cx="0" cy="0"/>
+          <a:chOff x="0" y="0"/>
+          <a:chExt cx="0" cy="0"/>
+        </a:xfrm>
+      </p:grpSpPr>
       <p:sp>
         <p:nvSpPr>
           <p:cNvPr id="2" name="Rectangle 1"/>
@@ -7836,6 +8011,7 @@
           <a:lstStyle/>
           <a:p>
             <a:pPr algn="ctr"/>
+            <a:endParaRPr/>
           </a:p>
         </p:txBody>
       </p:sp>
@@ -7879,6 +8055,7 @@
           <a:lstStyle/>
           <a:p>
             <a:pPr algn="ctr"/>
+            <a:endParaRPr/>
           </a:p>
         </p:txBody>
       </p:sp>
@@ -7922,6 +8099,7 @@
           <a:lstStyle/>
           <a:p>
             <a:pPr algn="ctr"/>
+            <a:endParaRPr/>
           </a:p>
         </p:txBody>
       </p:sp>
@@ -7965,6 +8143,7 @@
           <a:lstStyle/>
           <a:p>
             <a:pPr algn="ctr"/>
+            <a:endParaRPr/>
           </a:p>
         </p:txBody>
       </p:sp>
@@ -8008,6 +8187,7 @@
           <a:lstStyle/>
           <a:p>
             <a:pPr algn="ctr"/>
+            <a:endParaRPr/>
           </a:p>
         </p:txBody>
       </p:sp>
@@ -8051,6 +8231,7 @@
           <a:lstStyle/>
           <a:p>
             <a:pPr algn="ctr"/>
+            <a:endParaRPr/>
           </a:p>
         </p:txBody>
       </p:sp>
@@ -8094,6 +8275,7 @@
           <a:lstStyle/>
           <a:p>
             <a:pPr algn="ctr"/>
+            <a:endParaRPr/>
           </a:p>
         </p:txBody>
       </p:sp>
@@ -8137,6 +8319,7 @@
           <a:lstStyle/>
           <a:p>
             <a:pPr algn="ctr"/>
+            <a:endParaRPr/>
           </a:p>
         </p:txBody>
       </p:sp>
@@ -8178,7 +8361,7 @@
           </a:fontRef>
         </p:style>
         <p:txBody>
-          <a:bodyPr rtlCol="0" anchor="ctr" wrap="none"/>
+          <a:bodyPr wrap="none" rtlCol="0" anchor="ctr"/>
           <a:lstStyle/>
           <a:p>
             <a:pPr algn="ctr">
@@ -8328,6 +8511,7 @@
           <a:lstStyle/>
           <a:p>
             <a:pPr algn="ctr"/>
+            <a:endParaRPr/>
           </a:p>
         </p:txBody>
       </p:sp>
@@ -8383,6 +8567,7 @@
               <a:t>Những góp ý và hướng dẫn quý báu của Cô đã giúp dự án 3TG All-in-One hoàn thiện vượt bậc, đạt tiêu chuẩn ứng dụng thương mại thực tế với trải nghiệm người dùng cuốn hút, chuẩn chỉ và đẳng cấp!</a:t>
             </a:r>
             <a:br/>
+            <a:endParaRPr/>
           </a:p>
           <a:p>
             <a:pPr algn="ctr">
@@ -8412,11 +8597,23 @@
   <p:clrMapOvr>
     <a:masterClrMapping/>
   </p:clrMapOvr>
+  <mc:AlternateContent xmlns:mc="http://schemas.openxmlformats.org/markup-compatibility/2006">
+    <mc:Choice xmlns:p159="http://schemas.microsoft.com/office/powerpoint/2015/09/main" Requires="p159">
+      <p:transition xmlns:p14="http://schemas.microsoft.com/office/powerpoint/2010/main" spd="slow" p14:dur="2000">
+        <p159:morph option="byObject"/>
+      </p:transition>
+    </mc:Choice>
+    <mc:Fallback>
+      <p:transition spd="slow">
+        <p:fade/>
+      </p:transition>
+    </mc:Fallback>
+  </mc:AlternateContent>
 </p:sld>
 </file>
 
 <file path=ppt/slides/slide2.xml><?xml version="1.0" encoding="utf-8"?>
-<p:sld xmlns:a="http://schemas.openxmlformats.org/drawingml/2006/main" xmlns:p="http://schemas.openxmlformats.org/presentationml/2006/main" xmlns:r="http://schemas.openxmlformats.org/officeDocument/2006/relationships">
+<p:sld xmlns:a="http://schemas.openxmlformats.org/drawingml/2006/main" xmlns:r="http://schemas.openxmlformats.org/officeDocument/2006/relationships" xmlns:p="http://schemas.openxmlformats.org/presentationml/2006/main">
   <p:cSld>
     <p:spTree>
       <p:nvGrpSpPr>
@@ -8424,7 +8621,14 @@
         <p:cNvGrpSpPr/>
         <p:nvPr/>
       </p:nvGrpSpPr>
-      <p:grpSpPr/>
+      <p:grpSpPr>
+        <a:xfrm>
+          <a:off x="0" y="0"/>
+          <a:ext cx="0" cy="0"/>
+          <a:chOff x="0" y="0"/>
+          <a:chExt cx="0" cy="0"/>
+        </a:xfrm>
+      </p:grpSpPr>
       <p:sp>
         <p:nvSpPr>
           <p:cNvPr id="2" name="Rectangle 1"/>
@@ -8465,6 +8669,7 @@
           <a:lstStyle/>
           <a:p>
             <a:pPr algn="ctr"/>
+            <a:endParaRPr/>
           </a:p>
         </p:txBody>
       </p:sp>
@@ -8508,6 +8713,7 @@
           <a:lstStyle/>
           <a:p>
             <a:pPr algn="ctr"/>
+            <a:endParaRPr/>
           </a:p>
         </p:txBody>
       </p:sp>
@@ -8551,6 +8757,7 @@
           <a:lstStyle/>
           <a:p>
             <a:pPr algn="ctr"/>
+            <a:endParaRPr/>
           </a:p>
         </p:txBody>
       </p:sp>
@@ -8594,6 +8801,7 @@
           <a:lstStyle/>
           <a:p>
             <a:pPr algn="ctr"/>
+            <a:endParaRPr/>
           </a:p>
         </p:txBody>
       </p:sp>
@@ -8637,6 +8845,7 @@
           <a:lstStyle/>
           <a:p>
             <a:pPr algn="ctr"/>
+            <a:endParaRPr/>
           </a:p>
         </p:txBody>
       </p:sp>
@@ -8680,6 +8889,7 @@
           <a:lstStyle/>
           <a:p>
             <a:pPr algn="ctr"/>
+            <a:endParaRPr/>
           </a:p>
         </p:txBody>
       </p:sp>
@@ -8723,6 +8933,7 @@
           <a:lstStyle/>
           <a:p>
             <a:pPr algn="ctr"/>
+            <a:endParaRPr/>
           </a:p>
         </p:txBody>
       </p:sp>
@@ -8766,6 +8977,7 @@
           <a:lstStyle/>
           <a:p>
             <a:pPr algn="ctr"/>
+            <a:endParaRPr/>
           </a:p>
         </p:txBody>
       </p:sp>
@@ -8807,7 +9019,7 @@
           </a:fontRef>
         </p:style>
         <p:txBody>
-          <a:bodyPr rtlCol="0" anchor="ctr" wrap="none"/>
+          <a:bodyPr wrap="none" rtlCol="0" anchor="ctr"/>
           <a:lstStyle/>
           <a:p>
             <a:pPr algn="ctr">
@@ -8957,6 +9169,7 @@
           <a:lstStyle/>
           <a:p>
             <a:pPr algn="ctr"/>
+            <a:endParaRPr/>
           </a:p>
         </p:txBody>
       </p:sp>
@@ -9019,7 +9232,7 @@
           <a:lstStyle/>
           <a:p>
             <a:r>
-              <a:rPr b="1" sz="1100">
+              <a:rPr sz="1100" b="1">
                 <a:solidFill>
                   <a:srgbClr val="E11D48"/>
                 </a:solidFill>
@@ -9038,7 +9251,7 @@
           </a:p>
           <a:p>
             <a:r>
-              <a:rPr b="1" sz="1100">
+              <a:rPr sz="1100" b="1">
                 <a:solidFill>
                   <a:srgbClr val="E11D48"/>
                 </a:solidFill>
@@ -9057,7 +9270,7 @@
           </a:p>
           <a:p>
             <a:r>
-              <a:rPr b="1" sz="1100">
+              <a:rPr sz="1100" b="1">
                 <a:solidFill>
                   <a:srgbClr val="E11D48"/>
                 </a:solidFill>
@@ -9076,7 +9289,7 @@
           </a:p>
           <a:p>
             <a:r>
-              <a:rPr b="1" sz="1100">
+              <a:rPr sz="1100" b="1">
                 <a:solidFill>
                   <a:srgbClr val="E11D48"/>
                 </a:solidFill>
@@ -9137,6 +9350,7 @@
           <a:lstStyle/>
           <a:p>
             <a:pPr algn="ctr"/>
+            <a:endParaRPr/>
           </a:p>
         </p:txBody>
       </p:sp>
@@ -9199,7 +9413,7 @@
           <a:lstStyle/>
           <a:p>
             <a:r>
-              <a:rPr b="1" sz="1150">
+              <a:rPr sz="1150" b="1">
                 <a:solidFill>
                   <a:srgbClr val="1E3A8A"/>
                 </a:solidFill>
@@ -9222,7 +9436,7 @@
           </a:p>
           <a:p>
             <a:r>
-              <a:rPr b="1" sz="1150">
+              <a:rPr sz="1150" b="1">
                 <a:solidFill>
                   <a:srgbClr val="1E3A8A"/>
                 </a:solidFill>
@@ -9245,7 +9459,7 @@
           </a:p>
           <a:p>
             <a:r>
-              <a:rPr b="1" sz="1150">
+              <a:rPr sz="1150" b="1">
                 <a:solidFill>
                   <a:srgbClr val="1E3A8A"/>
                 </a:solidFill>
@@ -9273,11 +9487,23 @@
   <p:clrMapOvr>
     <a:masterClrMapping/>
   </p:clrMapOvr>
+  <mc:AlternateContent xmlns:mc="http://schemas.openxmlformats.org/markup-compatibility/2006">
+    <mc:Choice xmlns:p159="http://schemas.microsoft.com/office/powerpoint/2015/09/main" Requires="p159">
+      <p:transition xmlns:p14="http://schemas.microsoft.com/office/powerpoint/2010/main" spd="slow" p14:dur="2000">
+        <p159:morph option="byObject"/>
+      </p:transition>
+    </mc:Choice>
+    <mc:Fallback>
+      <p:transition spd="slow">
+        <p:fade/>
+      </p:transition>
+    </mc:Fallback>
+  </mc:AlternateContent>
 </p:sld>
 </file>
 
 <file path=ppt/slides/slide3.xml><?xml version="1.0" encoding="utf-8"?>
-<p:sld xmlns:a="http://schemas.openxmlformats.org/drawingml/2006/main" xmlns:p="http://schemas.openxmlformats.org/presentationml/2006/main" xmlns:r="http://schemas.openxmlformats.org/officeDocument/2006/relationships">
+<p:sld xmlns:a="http://schemas.openxmlformats.org/drawingml/2006/main" xmlns:r="http://schemas.openxmlformats.org/officeDocument/2006/relationships" xmlns:p="http://schemas.openxmlformats.org/presentationml/2006/main">
   <p:cSld>
     <p:spTree>
       <p:nvGrpSpPr>
@@ -9285,7 +9511,14 @@
         <p:cNvGrpSpPr/>
         <p:nvPr/>
       </p:nvGrpSpPr>
-      <p:grpSpPr/>
+      <p:grpSpPr>
+        <a:xfrm>
+          <a:off x="0" y="0"/>
+          <a:ext cx="0" cy="0"/>
+          <a:chOff x="0" y="0"/>
+          <a:chExt cx="0" cy="0"/>
+        </a:xfrm>
+      </p:grpSpPr>
       <p:sp>
         <p:nvSpPr>
           <p:cNvPr id="2" name="Rectangle 1"/>
@@ -9326,6 +9559,7 @@
           <a:lstStyle/>
           <a:p>
             <a:pPr algn="ctr"/>
+            <a:endParaRPr/>
           </a:p>
         </p:txBody>
       </p:sp>
@@ -9369,6 +9603,7 @@
           <a:lstStyle/>
           <a:p>
             <a:pPr algn="ctr"/>
+            <a:endParaRPr/>
           </a:p>
         </p:txBody>
       </p:sp>
@@ -9412,6 +9647,7 @@
           <a:lstStyle/>
           <a:p>
             <a:pPr algn="ctr"/>
+            <a:endParaRPr/>
           </a:p>
         </p:txBody>
       </p:sp>
@@ -9455,6 +9691,7 @@
           <a:lstStyle/>
           <a:p>
             <a:pPr algn="ctr"/>
+            <a:endParaRPr/>
           </a:p>
         </p:txBody>
       </p:sp>
@@ -9498,6 +9735,7 @@
           <a:lstStyle/>
           <a:p>
             <a:pPr algn="ctr"/>
+            <a:endParaRPr/>
           </a:p>
         </p:txBody>
       </p:sp>
@@ -9541,6 +9779,7 @@
           <a:lstStyle/>
           <a:p>
             <a:pPr algn="ctr"/>
+            <a:endParaRPr/>
           </a:p>
         </p:txBody>
       </p:sp>
@@ -9584,6 +9823,7 @@
           <a:lstStyle/>
           <a:p>
             <a:pPr algn="ctr"/>
+            <a:endParaRPr/>
           </a:p>
         </p:txBody>
       </p:sp>
@@ -9627,6 +9867,7 @@
           <a:lstStyle/>
           <a:p>
             <a:pPr algn="ctr"/>
+            <a:endParaRPr/>
           </a:p>
         </p:txBody>
       </p:sp>
@@ -9668,7 +9909,7 @@
           </a:fontRef>
         </p:style>
         <p:txBody>
-          <a:bodyPr rtlCol="0" anchor="ctr" wrap="none"/>
+          <a:bodyPr wrap="none" rtlCol="0" anchor="ctr"/>
           <a:lstStyle/>
           <a:p>
             <a:pPr algn="ctr">
@@ -9818,6 +10059,7 @@
           <a:lstStyle/>
           <a:p>
             <a:pPr algn="ctr"/>
+            <a:endParaRPr/>
           </a:p>
         </p:txBody>
       </p:sp>
@@ -9947,6 +10189,7 @@
           <a:lstStyle/>
           <a:p>
             <a:pPr algn="ctr"/>
+            <a:endParaRPr/>
           </a:p>
         </p:txBody>
       </p:sp>
@@ -10076,6 +10319,7 @@
           <a:lstStyle/>
           <a:p>
             <a:pPr algn="ctr"/>
+            <a:endParaRPr/>
           </a:p>
         </p:txBody>
       </p:sp>
@@ -10205,6 +10449,7 @@
           <a:lstStyle/>
           <a:p>
             <a:pPr algn="ctr"/>
+            <a:endParaRPr/>
           </a:p>
         </p:txBody>
       </p:sp>
@@ -10334,6 +10579,7 @@
           <a:lstStyle/>
           <a:p>
             <a:pPr algn="ctr"/>
+            <a:endParaRPr/>
           </a:p>
         </p:txBody>
       </p:sp>
@@ -10463,6 +10709,7 @@
           <a:lstStyle/>
           <a:p>
             <a:pPr algn="ctr"/>
+            <a:endParaRPr/>
           </a:p>
         </p:txBody>
       </p:sp>
@@ -10555,11 +10802,23 @@
   <p:clrMapOvr>
     <a:masterClrMapping/>
   </p:clrMapOvr>
+  <mc:AlternateContent xmlns:mc="http://schemas.openxmlformats.org/markup-compatibility/2006">
+    <mc:Choice xmlns:p159="http://schemas.microsoft.com/office/powerpoint/2015/09/main" Requires="p159">
+      <p:transition xmlns:p14="http://schemas.microsoft.com/office/powerpoint/2010/main" spd="slow" p14:dur="2000">
+        <p159:morph option="byObject"/>
+      </p:transition>
+    </mc:Choice>
+    <mc:Fallback>
+      <p:transition spd="slow">
+        <p:fade/>
+      </p:transition>
+    </mc:Fallback>
+  </mc:AlternateContent>
 </p:sld>
 </file>
 
 <file path=ppt/slides/slide4.xml><?xml version="1.0" encoding="utf-8"?>
-<p:sld xmlns:a="http://schemas.openxmlformats.org/drawingml/2006/main" xmlns:p="http://schemas.openxmlformats.org/presentationml/2006/main" xmlns:r="http://schemas.openxmlformats.org/officeDocument/2006/relationships">
+<p:sld xmlns:a="http://schemas.openxmlformats.org/drawingml/2006/main" xmlns:r="http://schemas.openxmlformats.org/officeDocument/2006/relationships" xmlns:p="http://schemas.openxmlformats.org/presentationml/2006/main">
   <p:cSld>
     <p:spTree>
       <p:nvGrpSpPr>
@@ -10567,7 +10826,14 @@
         <p:cNvGrpSpPr/>
         <p:nvPr/>
       </p:nvGrpSpPr>
-      <p:grpSpPr/>
+      <p:grpSpPr>
+        <a:xfrm>
+          <a:off x="0" y="0"/>
+          <a:ext cx="0" cy="0"/>
+          <a:chOff x="0" y="0"/>
+          <a:chExt cx="0" cy="0"/>
+        </a:xfrm>
+      </p:grpSpPr>
       <p:sp>
         <p:nvSpPr>
           <p:cNvPr id="2" name="Rectangle 1"/>
@@ -10608,6 +10874,7 @@
           <a:lstStyle/>
           <a:p>
             <a:pPr algn="ctr"/>
+            <a:endParaRPr/>
           </a:p>
         </p:txBody>
       </p:sp>
@@ -10651,6 +10918,7 @@
           <a:lstStyle/>
           <a:p>
             <a:pPr algn="ctr"/>
+            <a:endParaRPr/>
           </a:p>
         </p:txBody>
       </p:sp>
@@ -10694,6 +10962,7 @@
           <a:lstStyle/>
           <a:p>
             <a:pPr algn="ctr"/>
+            <a:endParaRPr/>
           </a:p>
         </p:txBody>
       </p:sp>
@@ -10737,6 +11006,7 @@
           <a:lstStyle/>
           <a:p>
             <a:pPr algn="ctr"/>
+            <a:endParaRPr/>
           </a:p>
         </p:txBody>
       </p:sp>
@@ -10780,6 +11050,7 @@
           <a:lstStyle/>
           <a:p>
             <a:pPr algn="ctr"/>
+            <a:endParaRPr/>
           </a:p>
         </p:txBody>
       </p:sp>
@@ -10823,6 +11094,7 @@
           <a:lstStyle/>
           <a:p>
             <a:pPr algn="ctr"/>
+            <a:endParaRPr/>
           </a:p>
         </p:txBody>
       </p:sp>
@@ -10866,6 +11138,7 @@
           <a:lstStyle/>
           <a:p>
             <a:pPr algn="ctr"/>
+            <a:endParaRPr/>
           </a:p>
         </p:txBody>
       </p:sp>
@@ -10909,6 +11182,7 @@
           <a:lstStyle/>
           <a:p>
             <a:pPr algn="ctr"/>
+            <a:endParaRPr/>
           </a:p>
         </p:txBody>
       </p:sp>
@@ -10950,7 +11224,7 @@
           </a:fontRef>
         </p:style>
         <p:txBody>
-          <a:bodyPr rtlCol="0" anchor="ctr" wrap="none"/>
+          <a:bodyPr wrap="none" rtlCol="0" anchor="ctr"/>
           <a:lstStyle/>
           <a:p>
             <a:pPr algn="ctr">
@@ -11100,6 +11374,7 @@
           <a:lstStyle/>
           <a:p>
             <a:pPr algn="ctr"/>
+            <a:endParaRPr/>
           </a:p>
         </p:txBody>
       </p:sp>
@@ -11251,6 +11526,7 @@
           <a:lstStyle/>
           <a:p>
             <a:pPr algn="ctr"/>
+            <a:endParaRPr/>
           </a:p>
         </p:txBody>
       </p:sp>
@@ -11361,11 +11637,23 @@
   <p:clrMapOvr>
     <a:masterClrMapping/>
   </p:clrMapOvr>
+  <mc:AlternateContent xmlns:mc="http://schemas.openxmlformats.org/markup-compatibility/2006">
+    <mc:Choice xmlns:p159="http://schemas.microsoft.com/office/powerpoint/2015/09/main" Requires="p159">
+      <p:transition xmlns:p14="http://schemas.microsoft.com/office/powerpoint/2010/main" spd="slow" p14:dur="2000">
+        <p159:morph option="byObject"/>
+      </p:transition>
+    </mc:Choice>
+    <mc:Fallback>
+      <p:transition spd="slow">
+        <p:fade/>
+      </p:transition>
+    </mc:Fallback>
+  </mc:AlternateContent>
 </p:sld>
 </file>
 
 <file path=ppt/slides/slide5.xml><?xml version="1.0" encoding="utf-8"?>
-<p:sld xmlns:a="http://schemas.openxmlformats.org/drawingml/2006/main" xmlns:p="http://schemas.openxmlformats.org/presentationml/2006/main" xmlns:r="http://schemas.openxmlformats.org/officeDocument/2006/relationships">
+<p:sld xmlns:a="http://schemas.openxmlformats.org/drawingml/2006/main" xmlns:r="http://schemas.openxmlformats.org/officeDocument/2006/relationships" xmlns:p="http://schemas.openxmlformats.org/presentationml/2006/main">
   <p:cSld>
     <p:spTree>
       <p:nvGrpSpPr>
@@ -11373,7 +11661,14 @@
         <p:cNvGrpSpPr/>
         <p:nvPr/>
       </p:nvGrpSpPr>
-      <p:grpSpPr/>
+      <p:grpSpPr>
+        <a:xfrm>
+          <a:off x="0" y="0"/>
+          <a:ext cx="0" cy="0"/>
+          <a:chOff x="0" y="0"/>
+          <a:chExt cx="0" cy="0"/>
+        </a:xfrm>
+      </p:grpSpPr>
       <p:sp>
         <p:nvSpPr>
           <p:cNvPr id="2" name="Rectangle 1"/>
@@ -11414,6 +11709,7 @@
           <a:lstStyle/>
           <a:p>
             <a:pPr algn="ctr"/>
+            <a:endParaRPr/>
           </a:p>
         </p:txBody>
       </p:sp>
@@ -11457,6 +11753,7 @@
           <a:lstStyle/>
           <a:p>
             <a:pPr algn="ctr"/>
+            <a:endParaRPr/>
           </a:p>
         </p:txBody>
       </p:sp>
@@ -11500,6 +11797,7 @@
           <a:lstStyle/>
           <a:p>
             <a:pPr algn="ctr"/>
+            <a:endParaRPr/>
           </a:p>
         </p:txBody>
       </p:sp>
@@ -11543,6 +11841,7 @@
           <a:lstStyle/>
           <a:p>
             <a:pPr algn="ctr"/>
+            <a:endParaRPr/>
           </a:p>
         </p:txBody>
       </p:sp>
@@ -11586,6 +11885,7 @@
           <a:lstStyle/>
           <a:p>
             <a:pPr algn="ctr"/>
+            <a:endParaRPr/>
           </a:p>
         </p:txBody>
       </p:sp>
@@ -11629,6 +11929,7 @@
           <a:lstStyle/>
           <a:p>
             <a:pPr algn="ctr"/>
+            <a:endParaRPr/>
           </a:p>
         </p:txBody>
       </p:sp>
@@ -11672,6 +11973,7 @@
           <a:lstStyle/>
           <a:p>
             <a:pPr algn="ctr"/>
+            <a:endParaRPr/>
           </a:p>
         </p:txBody>
       </p:sp>
@@ -11715,6 +12017,7 @@
           <a:lstStyle/>
           <a:p>
             <a:pPr algn="ctr"/>
+            <a:endParaRPr/>
           </a:p>
         </p:txBody>
       </p:sp>
@@ -11756,7 +12059,7 @@
           </a:fontRef>
         </p:style>
         <p:txBody>
-          <a:bodyPr rtlCol="0" anchor="ctr" wrap="none"/>
+          <a:bodyPr wrap="none" rtlCol="0" anchor="ctr"/>
           <a:lstStyle/>
           <a:p>
             <a:pPr algn="ctr">
@@ -11906,6 +12209,7 @@
           <a:lstStyle/>
           <a:p>
             <a:pPr algn="ctr"/>
+            <a:endParaRPr/>
           </a:p>
         </p:txBody>
       </p:sp>
@@ -12045,6 +12349,7 @@
           <a:lstStyle/>
           <a:p>
             <a:pPr algn="ctr"/>
+            <a:endParaRPr/>
           </a:p>
         </p:txBody>
       </p:sp>
@@ -12128,40 +12433,28 @@
           </a:p>
         </p:txBody>
       </p:sp>
-      <p:pic>
-        <p:nvPicPr>
-          <p:cNvPr id="19" name="Picture 18" descr="direct_chat.png"/>
-          <p:cNvPicPr>
-            <a:picLocks noChangeAspect="1"/>
-          </p:cNvPicPr>
-          <p:nvPr/>
-        </p:nvPicPr>
-        <p:blipFill>
-          <a:blip r:embed="rId2"/>
-          <a:stretch>
-            <a:fillRect/>
-          </a:stretch>
-        </p:blipFill>
-        <p:spPr>
-          <a:xfrm>
-            <a:off x="7589520" y="3017520"/>
-            <a:ext cx="2468880" cy="3719060"/>
-          </a:xfrm>
-          <a:prstGeom prst="rect">
-            <a:avLst/>
-          </a:prstGeom>
-        </p:spPr>
-      </p:pic>
     </p:spTree>
   </p:cSld>
   <p:clrMapOvr>
     <a:masterClrMapping/>
   </p:clrMapOvr>
+  <mc:AlternateContent xmlns:mc="http://schemas.openxmlformats.org/markup-compatibility/2006">
+    <mc:Choice xmlns:p159="http://schemas.microsoft.com/office/powerpoint/2015/09/main" Requires="p159">
+      <p:transition xmlns:p14="http://schemas.microsoft.com/office/powerpoint/2010/main" spd="slow" p14:dur="2000">
+        <p159:morph option="byObject"/>
+      </p:transition>
+    </mc:Choice>
+    <mc:Fallback>
+      <p:transition spd="slow">
+        <p:fade/>
+      </p:transition>
+    </mc:Fallback>
+  </mc:AlternateContent>
 </p:sld>
 </file>
 
 <file path=ppt/slides/slide6.xml><?xml version="1.0" encoding="utf-8"?>
-<p:sld xmlns:a="http://schemas.openxmlformats.org/drawingml/2006/main" xmlns:p="http://schemas.openxmlformats.org/presentationml/2006/main" xmlns:r="http://schemas.openxmlformats.org/officeDocument/2006/relationships">
+<p:sld xmlns:a="http://schemas.openxmlformats.org/drawingml/2006/main" xmlns:r="http://schemas.openxmlformats.org/officeDocument/2006/relationships" xmlns:p="http://schemas.openxmlformats.org/presentationml/2006/main">
   <p:cSld>
     <p:spTree>
       <p:nvGrpSpPr>
@@ -12169,7 +12462,14 @@
         <p:cNvGrpSpPr/>
         <p:nvPr/>
       </p:nvGrpSpPr>
-      <p:grpSpPr/>
+      <p:grpSpPr>
+        <a:xfrm>
+          <a:off x="0" y="0"/>
+          <a:ext cx="0" cy="0"/>
+          <a:chOff x="0" y="0"/>
+          <a:chExt cx="0" cy="0"/>
+        </a:xfrm>
+      </p:grpSpPr>
       <p:sp>
         <p:nvSpPr>
           <p:cNvPr id="2" name="Rectangle 1"/>
@@ -12210,6 +12510,7 @@
           <a:lstStyle/>
           <a:p>
             <a:pPr algn="ctr"/>
+            <a:endParaRPr/>
           </a:p>
         </p:txBody>
       </p:sp>
@@ -12253,6 +12554,7 @@
           <a:lstStyle/>
           <a:p>
             <a:pPr algn="ctr"/>
+            <a:endParaRPr/>
           </a:p>
         </p:txBody>
       </p:sp>
@@ -12296,6 +12598,7 @@
           <a:lstStyle/>
           <a:p>
             <a:pPr algn="ctr"/>
+            <a:endParaRPr/>
           </a:p>
         </p:txBody>
       </p:sp>
@@ -12339,6 +12642,7 @@
           <a:lstStyle/>
           <a:p>
             <a:pPr algn="ctr"/>
+            <a:endParaRPr/>
           </a:p>
         </p:txBody>
       </p:sp>
@@ -12382,6 +12686,7 @@
           <a:lstStyle/>
           <a:p>
             <a:pPr algn="ctr"/>
+            <a:endParaRPr/>
           </a:p>
         </p:txBody>
       </p:sp>
@@ -12425,6 +12730,7 @@
           <a:lstStyle/>
           <a:p>
             <a:pPr algn="ctr"/>
+            <a:endParaRPr/>
           </a:p>
         </p:txBody>
       </p:sp>
@@ -12468,6 +12774,7 @@
           <a:lstStyle/>
           <a:p>
             <a:pPr algn="ctr"/>
+            <a:endParaRPr/>
           </a:p>
         </p:txBody>
       </p:sp>
@@ -12511,6 +12818,7 @@
           <a:lstStyle/>
           <a:p>
             <a:pPr algn="ctr"/>
+            <a:endParaRPr/>
           </a:p>
         </p:txBody>
       </p:sp>
@@ -12552,7 +12860,7 @@
           </a:fontRef>
         </p:style>
         <p:txBody>
-          <a:bodyPr rtlCol="0" anchor="ctr" wrap="none"/>
+          <a:bodyPr wrap="none" rtlCol="0" anchor="ctr"/>
           <a:lstStyle/>
           <a:p>
             <a:pPr algn="ctr">
@@ -12702,6 +13010,7 @@
           <a:lstStyle/>
           <a:p>
             <a:pPr algn="ctr"/>
+            <a:endParaRPr/>
           </a:p>
         </p:txBody>
       </p:sp>
@@ -12840,6 +13149,7 @@
           <a:lstStyle/>
           <a:p>
             <a:pPr algn="ctr"/>
+            <a:endParaRPr/>
           </a:p>
         </p:txBody>
       </p:sp>
@@ -12952,11 +13262,23 @@
   <p:clrMapOvr>
     <a:masterClrMapping/>
   </p:clrMapOvr>
+  <mc:AlternateContent xmlns:mc="http://schemas.openxmlformats.org/markup-compatibility/2006">
+    <mc:Choice xmlns:p159="http://schemas.microsoft.com/office/powerpoint/2015/09/main" Requires="p159">
+      <p:transition xmlns:p14="http://schemas.microsoft.com/office/powerpoint/2010/main" spd="slow" p14:dur="2000">
+        <p159:morph option="byObject"/>
+      </p:transition>
+    </mc:Choice>
+    <mc:Fallback>
+      <p:transition spd="slow">
+        <p:fade/>
+      </p:transition>
+    </mc:Fallback>
+  </mc:AlternateContent>
 </p:sld>
 </file>
 
 <file path=ppt/slides/slide7.xml><?xml version="1.0" encoding="utf-8"?>
-<p:sld xmlns:a="http://schemas.openxmlformats.org/drawingml/2006/main" xmlns:p="http://schemas.openxmlformats.org/presentationml/2006/main" xmlns:r="http://schemas.openxmlformats.org/officeDocument/2006/relationships">
+<p:sld xmlns:a="http://schemas.openxmlformats.org/drawingml/2006/main" xmlns:r="http://schemas.openxmlformats.org/officeDocument/2006/relationships" xmlns:p="http://schemas.openxmlformats.org/presentationml/2006/main">
   <p:cSld>
     <p:spTree>
       <p:nvGrpSpPr>
@@ -12964,7 +13286,14 @@
         <p:cNvGrpSpPr/>
         <p:nvPr/>
       </p:nvGrpSpPr>
-      <p:grpSpPr/>
+      <p:grpSpPr>
+        <a:xfrm>
+          <a:off x="0" y="0"/>
+          <a:ext cx="0" cy="0"/>
+          <a:chOff x="0" y="0"/>
+          <a:chExt cx="0" cy="0"/>
+        </a:xfrm>
+      </p:grpSpPr>
       <p:sp>
         <p:nvSpPr>
           <p:cNvPr id="2" name="Rectangle 1"/>
@@ -13005,6 +13334,7 @@
           <a:lstStyle/>
           <a:p>
             <a:pPr algn="ctr"/>
+            <a:endParaRPr/>
           </a:p>
         </p:txBody>
       </p:sp>
@@ -13048,6 +13378,7 @@
           <a:lstStyle/>
           <a:p>
             <a:pPr algn="ctr"/>
+            <a:endParaRPr/>
           </a:p>
         </p:txBody>
       </p:sp>
@@ -13091,6 +13422,7 @@
           <a:lstStyle/>
           <a:p>
             <a:pPr algn="ctr"/>
+            <a:endParaRPr/>
           </a:p>
         </p:txBody>
       </p:sp>
@@ -13134,6 +13466,7 @@
           <a:lstStyle/>
           <a:p>
             <a:pPr algn="ctr"/>
+            <a:endParaRPr/>
           </a:p>
         </p:txBody>
       </p:sp>
@@ -13177,6 +13510,7 @@
           <a:lstStyle/>
           <a:p>
             <a:pPr algn="ctr"/>
+            <a:endParaRPr/>
           </a:p>
         </p:txBody>
       </p:sp>
@@ -13220,6 +13554,7 @@
           <a:lstStyle/>
           <a:p>
             <a:pPr algn="ctr"/>
+            <a:endParaRPr/>
           </a:p>
         </p:txBody>
       </p:sp>
@@ -13263,6 +13598,7 @@
           <a:lstStyle/>
           <a:p>
             <a:pPr algn="ctr"/>
+            <a:endParaRPr/>
           </a:p>
         </p:txBody>
       </p:sp>
@@ -13306,6 +13642,7 @@
           <a:lstStyle/>
           <a:p>
             <a:pPr algn="ctr"/>
+            <a:endParaRPr/>
           </a:p>
         </p:txBody>
       </p:sp>
@@ -13347,7 +13684,7 @@
           </a:fontRef>
         </p:style>
         <p:txBody>
-          <a:bodyPr rtlCol="0" anchor="ctr" wrap="none"/>
+          <a:bodyPr wrap="none" rtlCol="0" anchor="ctr"/>
           <a:lstStyle/>
           <a:p>
             <a:pPr algn="ctr">
@@ -13497,6 +13834,7 @@
           <a:lstStyle/>
           <a:p>
             <a:pPr algn="ctr"/>
+            <a:endParaRPr/>
           </a:p>
         </p:txBody>
       </p:sp>
@@ -13640,6 +13978,7 @@
           <a:lstStyle/>
           <a:p>
             <a:pPr algn="ctr"/>
+            <a:endParaRPr/>
           </a:p>
         </p:txBody>
       </p:sp>
@@ -13752,11 +14091,23 @@
   <p:clrMapOvr>
     <a:masterClrMapping/>
   </p:clrMapOvr>
+  <mc:AlternateContent xmlns:mc="http://schemas.openxmlformats.org/markup-compatibility/2006">
+    <mc:Choice xmlns:p159="http://schemas.microsoft.com/office/powerpoint/2015/09/main" Requires="p159">
+      <p:transition xmlns:p14="http://schemas.microsoft.com/office/powerpoint/2010/main" spd="slow" p14:dur="2000">
+        <p159:morph option="byObject"/>
+      </p:transition>
+    </mc:Choice>
+    <mc:Fallback>
+      <p:transition spd="slow">
+        <p:fade/>
+      </p:transition>
+    </mc:Fallback>
+  </mc:AlternateContent>
 </p:sld>
 </file>
 
 <file path=ppt/slides/slide8.xml><?xml version="1.0" encoding="utf-8"?>
-<p:sld xmlns:a="http://schemas.openxmlformats.org/drawingml/2006/main" xmlns:p="http://schemas.openxmlformats.org/presentationml/2006/main" xmlns:r="http://schemas.openxmlformats.org/officeDocument/2006/relationships">
+<p:sld xmlns:a="http://schemas.openxmlformats.org/drawingml/2006/main" xmlns:r="http://schemas.openxmlformats.org/officeDocument/2006/relationships" xmlns:p="http://schemas.openxmlformats.org/presentationml/2006/main">
   <p:cSld>
     <p:spTree>
       <p:nvGrpSpPr>
@@ -13764,7 +14115,14 @@
         <p:cNvGrpSpPr/>
         <p:nvPr/>
       </p:nvGrpSpPr>
-      <p:grpSpPr/>
+      <p:grpSpPr>
+        <a:xfrm>
+          <a:off x="0" y="0"/>
+          <a:ext cx="0" cy="0"/>
+          <a:chOff x="0" y="0"/>
+          <a:chExt cx="0" cy="0"/>
+        </a:xfrm>
+      </p:grpSpPr>
       <p:sp>
         <p:nvSpPr>
           <p:cNvPr id="2" name="Rectangle 1"/>
@@ -13805,6 +14163,7 @@
           <a:lstStyle/>
           <a:p>
             <a:pPr algn="ctr"/>
+            <a:endParaRPr/>
           </a:p>
         </p:txBody>
       </p:sp>
@@ -13848,6 +14207,7 @@
           <a:lstStyle/>
           <a:p>
             <a:pPr algn="ctr"/>
+            <a:endParaRPr/>
           </a:p>
         </p:txBody>
       </p:sp>
@@ -13891,6 +14251,7 @@
           <a:lstStyle/>
           <a:p>
             <a:pPr algn="ctr"/>
+            <a:endParaRPr/>
           </a:p>
         </p:txBody>
       </p:sp>
@@ -13934,6 +14295,7 @@
           <a:lstStyle/>
           <a:p>
             <a:pPr algn="ctr"/>
+            <a:endParaRPr/>
           </a:p>
         </p:txBody>
       </p:sp>
@@ -13977,6 +14339,7 @@
           <a:lstStyle/>
           <a:p>
             <a:pPr algn="ctr"/>
+            <a:endParaRPr/>
           </a:p>
         </p:txBody>
       </p:sp>
@@ -14020,6 +14383,7 @@
           <a:lstStyle/>
           <a:p>
             <a:pPr algn="ctr"/>
+            <a:endParaRPr/>
           </a:p>
         </p:txBody>
       </p:sp>
@@ -14063,6 +14427,7 @@
           <a:lstStyle/>
           <a:p>
             <a:pPr algn="ctr"/>
+            <a:endParaRPr/>
           </a:p>
         </p:txBody>
       </p:sp>
@@ -14106,6 +14471,7 @@
           <a:lstStyle/>
           <a:p>
             <a:pPr algn="ctr"/>
+            <a:endParaRPr/>
           </a:p>
         </p:txBody>
       </p:sp>
@@ -14147,7 +14513,7 @@
           </a:fontRef>
         </p:style>
         <p:txBody>
-          <a:bodyPr rtlCol="0" anchor="ctr" wrap="none"/>
+          <a:bodyPr wrap="none" rtlCol="0" anchor="ctr"/>
           <a:lstStyle/>
           <a:p>
             <a:pPr algn="ctr">
@@ -14297,6 +14663,7 @@
           <a:lstStyle/>
           <a:p>
             <a:pPr algn="ctr"/>
+            <a:endParaRPr/>
           </a:p>
         </p:txBody>
       </p:sp>
@@ -14448,6 +14815,7 @@
           <a:lstStyle/>
           <a:p>
             <a:pPr algn="ctr"/>
+            <a:endParaRPr/>
           </a:p>
         </p:txBody>
       </p:sp>
@@ -14603,6 +14971,7 @@
           <a:lstStyle/>
           <a:p>
             <a:pPr algn="ctr"/>
+            <a:endParaRPr/>
           </a:p>
         </p:txBody>
       </p:sp>
@@ -14721,11 +15090,23 @@
   <p:clrMapOvr>
     <a:masterClrMapping/>
   </p:clrMapOvr>
+  <mc:AlternateContent xmlns:mc="http://schemas.openxmlformats.org/markup-compatibility/2006">
+    <mc:Choice xmlns:p159="http://schemas.microsoft.com/office/powerpoint/2015/09/main" Requires="p159">
+      <p:transition xmlns:p14="http://schemas.microsoft.com/office/powerpoint/2010/main" spd="slow" p14:dur="2000">
+        <p159:morph option="byObject"/>
+      </p:transition>
+    </mc:Choice>
+    <mc:Fallback>
+      <p:transition spd="slow">
+        <p:fade/>
+      </p:transition>
+    </mc:Fallback>
+  </mc:AlternateContent>
 </p:sld>
 </file>
 
 <file path=ppt/slides/slide9.xml><?xml version="1.0" encoding="utf-8"?>
-<p:sld xmlns:a="http://schemas.openxmlformats.org/drawingml/2006/main" xmlns:p="http://schemas.openxmlformats.org/presentationml/2006/main" xmlns:r="http://schemas.openxmlformats.org/officeDocument/2006/relationships">
+<p:sld xmlns:a="http://schemas.openxmlformats.org/drawingml/2006/main" xmlns:r="http://schemas.openxmlformats.org/officeDocument/2006/relationships" xmlns:p="http://schemas.openxmlformats.org/presentationml/2006/main">
   <p:cSld>
     <p:spTree>
       <p:nvGrpSpPr>
@@ -14733,7 +15114,14 @@
         <p:cNvGrpSpPr/>
         <p:nvPr/>
       </p:nvGrpSpPr>
-      <p:grpSpPr/>
+      <p:grpSpPr>
+        <a:xfrm>
+          <a:off x="0" y="0"/>
+          <a:ext cx="0" cy="0"/>
+          <a:chOff x="0" y="0"/>
+          <a:chExt cx="0" cy="0"/>
+        </a:xfrm>
+      </p:grpSpPr>
       <p:sp>
         <p:nvSpPr>
           <p:cNvPr id="2" name="Rectangle 1"/>
@@ -14774,6 +15162,7 @@
           <a:lstStyle/>
           <a:p>
             <a:pPr algn="ctr"/>
+            <a:endParaRPr/>
           </a:p>
         </p:txBody>
       </p:sp>
@@ -14817,6 +15206,7 @@
           <a:lstStyle/>
           <a:p>
             <a:pPr algn="ctr"/>
+            <a:endParaRPr/>
           </a:p>
         </p:txBody>
       </p:sp>
@@ -14860,6 +15250,7 @@
           <a:lstStyle/>
           <a:p>
             <a:pPr algn="ctr"/>
+            <a:endParaRPr/>
           </a:p>
         </p:txBody>
       </p:sp>
@@ -14903,6 +15294,7 @@
           <a:lstStyle/>
           <a:p>
             <a:pPr algn="ctr"/>
+            <a:endParaRPr/>
           </a:p>
         </p:txBody>
       </p:sp>
@@ -14946,6 +15338,7 @@
           <a:lstStyle/>
           <a:p>
             <a:pPr algn="ctr"/>
+            <a:endParaRPr/>
           </a:p>
         </p:txBody>
       </p:sp>
@@ -14989,6 +15382,7 @@
           <a:lstStyle/>
           <a:p>
             <a:pPr algn="ctr"/>
+            <a:endParaRPr/>
           </a:p>
         </p:txBody>
       </p:sp>
@@ -15032,6 +15426,7 @@
           <a:lstStyle/>
           <a:p>
             <a:pPr algn="ctr"/>
+            <a:endParaRPr/>
           </a:p>
         </p:txBody>
       </p:sp>
@@ -15075,6 +15470,7 @@
           <a:lstStyle/>
           <a:p>
             <a:pPr algn="ctr"/>
+            <a:endParaRPr/>
           </a:p>
         </p:txBody>
       </p:sp>
@@ -15116,7 +15512,7 @@
           </a:fontRef>
         </p:style>
         <p:txBody>
-          <a:bodyPr rtlCol="0" anchor="ctr" wrap="none"/>
+          <a:bodyPr wrap="none" rtlCol="0" anchor="ctr"/>
           <a:lstStyle/>
           <a:p>
             <a:pPr algn="ctr">
@@ -15266,6 +15662,7 @@
           <a:lstStyle/>
           <a:p>
             <a:pPr algn="ctr"/>
+            <a:endParaRPr/>
           </a:p>
         </p:txBody>
       </p:sp>
@@ -15413,6 +15810,7 @@
           <a:lstStyle/>
           <a:p>
             <a:pPr algn="ctr"/>
+            <a:endParaRPr/>
           </a:p>
         </p:txBody>
       </p:sp>
@@ -15525,6 +15923,18 @@
   <p:clrMapOvr>
     <a:masterClrMapping/>
   </p:clrMapOvr>
+  <mc:AlternateContent xmlns:mc="http://schemas.openxmlformats.org/markup-compatibility/2006">
+    <mc:Choice xmlns:p159="http://schemas.microsoft.com/office/powerpoint/2015/09/main" Requires="p159">
+      <p:transition xmlns:p14="http://schemas.microsoft.com/office/powerpoint/2010/main" spd="slow" p14:dur="2000">
+        <p159:morph option="byObject"/>
+      </p:transition>
+    </mc:Choice>
+    <mc:Fallback>
+      <p:transition spd="slow">
+        <p:fade/>
+      </p:transition>
+    </mc:Fallback>
+  </mc:AlternateContent>
 </p:sld>
 </file>
 

</xml_diff>